<commit_message>
Añadidos nuevos archivos .pdf y .pptx
Enlace del repo añadido a la presentación y pdf
</commit_message>
<xml_diff>
--- a/docs/Bases_de_Datos_Relacionales_SQL.pptx
+++ b/docs/Bases_de_Datos_Relacionales_SQL.pptx
@@ -21788,8 +21788,8 @@
         </p:nvSpPr>
         <p:spPr>
           <a:xfrm>
-            <a:off x="1645920" y="4114800"/>
-            <a:ext cx="8869680" cy="548640"/>
+            <a:off x="731520" y="4297680"/>
+            <a:ext cx="10698480" cy="548640"/>
           </a:xfrm>
           <a:prstGeom prst="rect">
             <a:avLst/>
@@ -21805,17 +21805,17 @@
               <a:buNone/>
             </a:pPr>
             <a:r>
-              <a:rPr lang="en-US" sz="1600" i="1" dirty="0">
-                <a:solidFill>
-                  <a:srgbClr val="C9D6E3"/>
+              <a:rPr lang="en-US" sz="1800" b="1" dirty="0">
+                <a:solidFill>
+                  <a:srgbClr val="9FD8E8"/>
                 </a:solidFill>
                 <a:latin typeface="Calibri" pitchFamily="34" charset="0"/>
                 <a:ea typeface="Calibri" pitchFamily="34" charset="-122"/>
                 <a:cs typeface="Calibri" pitchFamily="34" charset="-120"/>
               </a:rPr>
-              <a:t>¿Qué pasaría si no usáramos una clave foránea entre estas dos tablas?</a:t>
-            </a:r>
-            <a:endParaRPr lang="en-US" sz="1600" dirty="0"/>
+              <a:t>¡Gracias!</a:t>
+            </a:r>
+            <a:endParaRPr lang="en-US" sz="1800" dirty="0"/>
           </a:p>
         </p:txBody>
       </p:sp>
@@ -21828,7 +21828,7 @@
         <p:spPr>
           <a:xfrm>
             <a:off x="731520" y="5120640"/>
-            <a:ext cx="10698480" cy="548640"/>
+            <a:ext cx="10698480" cy="365760"/>
           </a:xfrm>
           <a:prstGeom prst="rect">
             <a:avLst/>
@@ -21844,17 +21844,65 @@
               <a:buNone/>
             </a:pPr>
             <a:r>
-              <a:rPr lang="en-US" sz="1800" b="1" dirty="0">
-                <a:solidFill>
-                  <a:srgbClr val="9FD8E8"/>
+              <a:rPr lang="en-US" sz="1300" dirty="0">
+                <a:solidFill>
+                  <a:srgbClr val="C9D6E3"/>
                 </a:solidFill>
                 <a:latin typeface="Calibri" pitchFamily="34" charset="0"/>
                 <a:ea typeface="Calibri" pitchFamily="34" charset="-122"/>
                 <a:cs typeface="Calibri" pitchFamily="34" charset="-120"/>
               </a:rPr>
-              <a:t>¡Gracias!</a:t>
-            </a:r>
-            <a:endParaRPr lang="en-US" sz="1800" dirty="0"/>
+              <a:t>Código y material en GitHub</a:t>
+            </a:r>
+            <a:endParaRPr lang="en-US" sz="1300" dirty="0"/>
+          </a:p>
+        </p:txBody>
+      </p:sp>
+      <p:sp>
+        <p:nvSpPr>
+          <p:cNvPr id="7" name="Text 4">
+            <a:hlinkClick r:id="rId2" tooltip=""/>
+          </p:cNvPr>
+          <p:cNvSpPr/>
+          <p:nvPr/>
+        </p:nvSpPr>
+        <p:spPr>
+          <a:xfrm>
+            <a:off x="731520" y="5440680"/>
+            <a:ext cx="10698480" cy="411480"/>
+          </a:xfrm>
+          <a:prstGeom prst="rect">
+            <a:avLst/>
+          </a:prstGeom>
+          <a:noFill/>
+          <a:ln/>
+        </p:spPr>
+        <p:txBody>
+          <a:bodyPr wrap="square" rtlCol="0" anchor="ctr"/>
+          <a:lstStyle/>
+          <a:p>
+            <a:pPr algn="ctr" indent="0" marL="0">
+              <a:buNone/>
+            </a:pPr>
+            <a:r>
+              <a:rPr lang="en-US" sz="1600" b="1" u="sng" dirty="0">
+                <a:solidFill>
+                  <a:srgbClr val="FFFFFF"/>
+                </a:solidFill>
+                <a:latin typeface="Calibri" pitchFamily="34" charset="0"/>
+                <a:ea typeface="Calibri" pitchFamily="34" charset="-122"/>
+                <a:cs typeface="Calibri" pitchFamily="34" charset="-120"/>
+                <a:hlinkClick r:id="rId2" invalidUrl="" action="" tgtFrame="" tooltip="" history="1" highlightClick="0" endSnd="0">
+                  <a:extLst>
+                    <a:ext uri="{A12FA001-AC4F-418D-AE19-62706E023703}">
+                      <ahyp:hlinkClr xmlns:ahyp="http://schemas.microsoft.com/office/drawing/2018/hyperlinkcolor" val="tx"/>
+                    </a:ext>
+                  </a:extLst>
+                </a:hlinkClick>
+              </a:rPr>
+              <a:t>github.com/arita-pereira/bases-de-datos-relacionales-sql</a:t>
+            </a:r>
+            <a:endParaRPr lang="en-US" sz="1600" dirty="0"/>
           </a:p>
         </p:txBody>
       </p:sp>

</xml_diff>